<commit_message>
Session 6 pre-flight (John's review) + global leadsanion repair
Companion Demo gains a worked sample of the naming + blessing pattern
(slide-11 style); homework slide drops the quarter break and the paper
Quarterly Pulse (Examen carried through the two weeks; run sheet,
take-home sheet, and the on-screen sheet images updated to match);
Three Questions reframed as a thinking point (no quarterly break, 'next
evening we talk', 'next quarter' dropped from Q1). 'leadsanion' -> Lead
Companion across all ten decks that still carried it (15 instances).
All leader notes rebuilt; new tools/sync-evening-to-onedrive.py is the
standing sync (97 artifacts to Evenings at Home per the filing map).

Co-Authored-By: Claude Fable 5 <noreply@anthropic.com>
</commit_message>
<xml_diff>
--- a/_implementation-notes/evening-series/FotH Evening Session 13 Slides DRAFT v1.pptx
+++ b/_implementation-notes/evening-series/FotH Evening Session 13 Slides DRAFT v1.pptx
@@ -1502,7 +1502,7 @@
           <a:p>
             <a:r>
               <a:rPr lang="en-US" sz="1200"/>
-              <a:t>BEATS: 1. Ask no one to repeat their downhill answer — what was named in the pair stays there. 2. One sentence per leadsanion: a general observation, no names. 3. One brief observation from you across the room. 4. Land it: today's answer is a working draft — closer to true than the resume version, and it will deepen.</a:t>
+              <a:t>BEATS: 1. Ask no one to repeat their downhill answer — what was named in the pair stays there. 2. One sentence per Lead Companion: a general observation, no names. 3. One brief observation from you across the room. 4. Land it: today's answer is a working draft — closer to true than the resume version, and it will deepen.</a:t>
             </a:r>
           </a:p>
           <a:p>
@@ -5339,7 +5339,7 @@
                 </a:solidFill>
                 <a:latin typeface="Calibri"/>
               </a:rPr>
-              <a:t>One sentence from each leadsanion — one general thing they noticed, not a specific person</a:t>
+              <a:t>One sentence from each Lead Companion — one general thing they noticed, not a specific person</a:t>
             </a:r>
           </a:p>
           <a:p>

</xml_diff>